<commit_message>
Build Session 22: demo feedback and CP10 scoring sheets, deck, student page
- Demo Feedback Sheet (anonymous half-sheet pair, one half per demo) and
  an instructor CP10 Scoring Sheet grouped by when each criterion is
  scored: carried over, live, from the cp10 tag
- Demos run 6 min + 2 min questions + 1 min to swap; setup and debrief
  lose a minute each (Session 21 slide, page, and outline match)
- The proven-or-shown test ("if the claim were false, would the demo
  have looked different?") on a new slide, the feedback sheet, the
  student page, and the CP10 handout
- Audit pairings and repo URLs set on the board at the start of class
  from attendance; no peer evaluation this term (no teams)
- Session 22 outline v2 committed after review; 10-slide deck; student
  page published

Co-Authored-By: Claude Opus 5.5 <noreply@anthropic.com>
</commit_message>
<xml_diff>
--- a/canvas_material/lectures/powerpoint/Session21-CheckInStudio.pptx
+++ b/canvas_material/lectures/powerpoint/Session21-CheckInStudio.pptx
@@ -690,7 +690,7 @@
           <a:p>
             <a:r>
               <a:rPr lang="en-US" dirty="0"/>
-              <a:t>Five minutes with the next two slides. Write the demo order and audit pairings on the board before you show this; pairings are the review partners from Session 20. Time-boxes are hard on Wednesday: a demo that runs long takes time from someone else's. Class barely touches demo craft today, so point them at the CP10 assignment and the Session 22 page tonight. CP9 goes in through Canvas before class, not during it.</a:t>
+              <a:t>Five minutes with the next two slides. Write the demo order on the board before you show this. Audit pairings wait for Wednesday's attendance (the Session 20 review partners where both are there). Time-boxes are hard on Wednesday: a demo that runs long takes time from someone else's. Class barely touches demo craft today, so point them at the CP10 assignment and the Session 22 page tonight. CP9 goes in through Canvas before class, not during it.</a:t>
             </a:r>
             <a:endParaRPr lang="en-US" dirty="0"/>
           </a:p>
@@ -3831,7 +3831,7 @@
                 <a:ea typeface="Calibri" pitchFamily="34" charset="-122"/>
                 <a:cs typeface="Calibri" pitchFamily="34" charset="-120"/>
               </a:rPr>
-              <a:t>4 min</a:t>
+              <a:t>3 min</a:t>
             </a:r>
             <a:endParaRPr lang="en-US" sz="1700" dirty="0"/>
           </a:p>
@@ -3977,7 +3977,7 @@
                 <a:ea typeface="Calibri" pitchFamily="34" charset="-122"/>
                 <a:cs typeface="Calibri" pitchFamily="34" charset="-120"/>
               </a:rPr>
-              <a:t>~34 min</a:t>
+              <a:t>36 min</a:t>
             </a:r>
             <a:endParaRPr lang="en-US" sz="1700" dirty="0"/>
           </a:p>
@@ -4055,7 +4055,7 @@
                 <a:ea typeface="Calibri" pitchFamily="34" charset="-122"/>
                 <a:cs typeface="Calibri" pitchFamily="34" charset="-120"/>
               </a:rPr>
-              <a:t>About 6 min each, then 3 min of questions. Read ahead: the CP10 assignment and the Session 22 page.</a:t>
+              <a:t>6 min each, 2 of questions, 1 to swap. Read ahead: the CP10 assignment and the Session 22 page.</a:t>
             </a:r>
             <a:endParaRPr lang="en-US" sz="1600" dirty="0"/>
           </a:p>
@@ -4269,7 +4269,7 @@
                 <a:ea typeface="Calibri" pitchFamily="34" charset="-122"/>
                 <a:cs typeface="Calibri" pitchFamily="34" charset="-120"/>
               </a:rPr>
-              <a:t>5 min</a:t>
+              <a:t>4 min</a:t>
             </a:r>
             <a:endParaRPr lang="en-US" sz="1700" dirty="0"/>
           </a:p>
@@ -4429,7 +4429,7 @@
                 <a:ea typeface="Calibri" pitchFamily="34" charset="-122"/>
                 <a:cs typeface="Calibri" pitchFamily="34" charset="-120"/>
               </a:rPr>
-              <a:t>demo order and audit pairings. Write yours down.</a:t>
+              <a:t>the demo order. Audit pairings are set Wednesday, from who's here.</a:t>
             </a:r>
             <a:endParaRPr lang="en-US" sz="1800" dirty="0"/>
           </a:p>

</xml_diff>